<commit_message>
Fathah decks: add animal and bird friends on every slide (shared sprites with kasrah decks)
Co-Authored-By: Claude Opus 5.5 <noreply@anthropic.com>
Claude-Session: https://claude.ai/code/session_01XjTEwQ8YdBa1SjcPiYTm9z
</commit_message>
<xml_diff>
--- a/fathah-plus/01-alif.pptx
+++ b/fathah-plus/01-alif.pptx
@@ -3428,6 +3428,78 @@
           </a:p>
         </p:txBody>
       </p:sp>
+      <p:pic>
+        <p:nvPicPr>
+          <p:cNvPr id="14" name="Image 0" descr="fish">    </p:cNvPr>
+          <p:cNvPicPr>
+            <a:picLocks noChangeAspect="1"/>
+          </p:cNvPicPr>
+          <p:nvPr/>
+        </p:nvPicPr>
+        <p:blipFill>
+          <a:blip r:embed="rId1"/>
+          <a:stretch>
+            <a:fillRect/>
+          </a:stretch>
+        </p:blipFill>
+        <p:spPr>
+          <a:xfrm>
+            <a:off x="91440" y="1783080"/>
+            <a:ext cx="1932219" cy="1554480"/>
+          </a:xfrm>
+          <a:prstGeom prst="rect">
+            <a:avLst/>
+          </a:prstGeom>
+        </p:spPr>
+      </p:pic>
+      <p:pic>
+        <p:nvPicPr>
+          <p:cNvPr id="15" name="Image 1" descr="bird">    </p:cNvPr>
+          <p:cNvPicPr>
+            <a:picLocks noChangeAspect="1"/>
+          </p:cNvPicPr>
+          <p:nvPr/>
+        </p:nvPicPr>
+        <p:blipFill>
+          <a:blip r:embed="rId2"/>
+          <a:stretch>
+            <a:fillRect/>
+          </a:stretch>
+        </p:blipFill>
+        <p:spPr>
+          <a:xfrm>
+            <a:off x="7836957" y="1783080"/>
+            <a:ext cx="1215603" cy="1554480"/>
+          </a:xfrm>
+          <a:prstGeom prst="rect">
+            <a:avLst/>
+          </a:prstGeom>
+        </p:spPr>
+      </p:pic>
+      <p:pic>
+        <p:nvPicPr>
+          <p:cNvPr id="16" name="Image 2" descr="bee">    </p:cNvPr>
+          <p:cNvPicPr>
+            <a:picLocks noChangeAspect="1"/>
+          </p:cNvPicPr>
+          <p:nvPr/>
+        </p:nvPicPr>
+        <p:blipFill>
+          <a:blip r:embed="rId3"/>
+          <a:stretch>
+            <a:fillRect/>
+          </a:stretch>
+        </p:blipFill>
+        <p:spPr>
+          <a:xfrm>
+            <a:off x="5507248" y="45720"/>
+            <a:ext cx="802112" cy="777240"/>
+          </a:xfrm>
+          <a:prstGeom prst="rect">
+            <a:avLst/>
+          </a:prstGeom>
+        </p:spPr>
+      </p:pic>
     </p:spTree>
   </p:cSld>
   <p:clrMapOvr>
@@ -4453,6 +4525,30 @@
           </a:p>
         </p:txBody>
       </p:sp>
+      <p:pic>
+        <p:nvPicPr>
+          <p:cNvPr id="32" name="Image 0" descr="bird4">    </p:cNvPr>
+          <p:cNvPicPr>
+            <a:picLocks noChangeAspect="1"/>
+          </p:cNvPicPr>
+          <p:nvPr/>
+        </p:nvPicPr>
+        <p:blipFill>
+          <a:blip r:embed="rId1"/>
+          <a:stretch>
+            <a:fillRect/>
+          </a:stretch>
+        </p:blipFill>
+        <p:spPr>
+          <a:xfrm>
+            <a:off x="1005840" y="45720"/>
+            <a:ext cx="1007303" cy="777240"/>
+          </a:xfrm>
+          <a:prstGeom prst="rect">
+            <a:avLst/>
+          </a:prstGeom>
+        </p:spPr>
+      </p:pic>
     </p:spTree>
   </p:cSld>
   <p:clrMapOvr>
@@ -5842,6 +5938,54 @@
           </a:p>
         </p:txBody>
       </p:sp>
+      <p:pic>
+        <p:nvPicPr>
+          <p:cNvPr id="29" name="Image 0" descr="duck">    </p:cNvPr>
+          <p:cNvPicPr>
+            <a:picLocks noChangeAspect="1"/>
+          </p:cNvPicPr>
+          <p:nvPr/>
+        </p:nvPicPr>
+        <p:blipFill>
+          <a:blip r:embed="rId1"/>
+          <a:stretch>
+            <a:fillRect/>
+          </a:stretch>
+        </p:blipFill>
+        <p:spPr>
+          <a:xfrm>
+            <a:off x="91440" y="3977640"/>
+            <a:ext cx="927202" cy="1097280"/>
+          </a:xfrm>
+          <a:prstGeom prst="rect">
+            <a:avLst/>
+          </a:prstGeom>
+        </p:spPr>
+      </p:pic>
+      <p:pic>
+        <p:nvPicPr>
+          <p:cNvPr id="30" name="Image 1" descr="bee">    </p:cNvPr>
+          <p:cNvPicPr>
+            <a:picLocks noChangeAspect="1"/>
+          </p:cNvPicPr>
+          <p:nvPr/>
+        </p:nvPicPr>
+        <p:blipFill>
+          <a:blip r:embed="rId2"/>
+          <a:stretch>
+            <a:fillRect/>
+          </a:stretch>
+        </p:blipFill>
+        <p:spPr>
+          <a:xfrm>
+            <a:off x="5507248" y="45720"/>
+            <a:ext cx="802112" cy="777240"/>
+          </a:xfrm>
+          <a:prstGeom prst="rect">
+            <a:avLst/>
+          </a:prstGeom>
+        </p:spPr>
+      </p:pic>
     </p:spTree>
   </p:cSld>
   <p:clrMapOvr>
@@ -7104,6 +7248,78 @@
           </a:p>
         </p:txBody>
       </p:sp>
+      <p:pic>
+        <p:nvPicPr>
+          <p:cNvPr id="24" name="Image 0" descr="dog">    </p:cNvPr>
+          <p:cNvPicPr>
+            <a:picLocks noChangeAspect="1"/>
+          </p:cNvPicPr>
+          <p:nvPr/>
+        </p:nvPicPr>
+        <p:blipFill>
+          <a:blip r:embed="rId1"/>
+          <a:stretch>
+            <a:fillRect/>
+          </a:stretch>
+        </p:blipFill>
+        <p:spPr>
+          <a:xfrm>
+            <a:off x="91440" y="3566160"/>
+            <a:ext cx="1425778" cy="1508760"/>
+          </a:xfrm>
+          <a:prstGeom prst="rect">
+            <a:avLst/>
+          </a:prstGeom>
+        </p:spPr>
+      </p:pic>
+      <p:pic>
+        <p:nvPicPr>
+          <p:cNvPr id="25" name="Image 1" descr="bird">    </p:cNvPr>
+          <p:cNvPicPr>
+            <a:picLocks noChangeAspect="1"/>
+          </p:cNvPicPr>
+          <p:nvPr/>
+        </p:nvPicPr>
+        <p:blipFill>
+          <a:blip r:embed="rId2"/>
+          <a:stretch>
+            <a:fillRect/>
+          </a:stretch>
+        </p:blipFill>
+        <p:spPr>
+          <a:xfrm>
+            <a:off x="7758227" y="3337560"/>
+            <a:ext cx="1294333" cy="1737360"/>
+          </a:xfrm>
+          <a:prstGeom prst="rect">
+            <a:avLst/>
+          </a:prstGeom>
+        </p:spPr>
+      </p:pic>
+      <p:pic>
+        <p:nvPicPr>
+          <p:cNvPr id="26" name="Image 2" descr="bird2">    </p:cNvPr>
+          <p:cNvPicPr>
+            <a:picLocks noChangeAspect="1"/>
+          </p:cNvPicPr>
+          <p:nvPr/>
+        </p:nvPicPr>
+        <p:blipFill>
+          <a:blip r:embed="rId3"/>
+          <a:stretch>
+            <a:fillRect/>
+          </a:stretch>
+        </p:blipFill>
+        <p:spPr>
+          <a:xfrm>
+            <a:off x="1920240" y="45720"/>
+            <a:ext cx="918789" cy="731520"/>
+          </a:xfrm>
+          <a:prstGeom prst="rect">
+            <a:avLst/>
+          </a:prstGeom>
+        </p:spPr>
+      </p:pic>
     </p:spTree>
   </p:cSld>
   <p:clrMapOvr>
@@ -8391,6 +8607,54 @@
           </a:p>
         </p:txBody>
       </p:sp>
+      <p:pic>
+        <p:nvPicPr>
+          <p:cNvPr id="25" name="Image 0" descr="cat">    </p:cNvPr>
+          <p:cNvPicPr>
+            <a:picLocks noChangeAspect="1"/>
+          </p:cNvPicPr>
+          <p:nvPr/>
+        </p:nvPicPr>
+        <p:blipFill>
+          <a:blip r:embed="rId1"/>
+          <a:stretch>
+            <a:fillRect/>
+          </a:stretch>
+        </p:blipFill>
+        <p:spPr>
+          <a:xfrm>
+            <a:off x="91440" y="3794760"/>
+            <a:ext cx="1089416" cy="1280160"/>
+          </a:xfrm>
+          <a:prstGeom prst="rect">
+            <a:avLst/>
+          </a:prstGeom>
+        </p:spPr>
+      </p:pic>
+      <p:pic>
+        <p:nvPicPr>
+          <p:cNvPr id="26" name="Image 1" descr="butterfly1">    </p:cNvPr>
+          <p:cNvPicPr>
+            <a:picLocks noChangeAspect="1"/>
+          </p:cNvPicPr>
+          <p:nvPr/>
+        </p:nvPicPr>
+        <p:blipFill>
+          <a:blip r:embed="rId2"/>
+          <a:stretch>
+            <a:fillRect/>
+          </a:stretch>
+        </p:blipFill>
+        <p:spPr>
+          <a:xfrm>
+            <a:off x="5403098" y="45720"/>
+            <a:ext cx="906262" cy="777240"/>
+          </a:xfrm>
+          <a:prstGeom prst="rect">
+            <a:avLst/>
+          </a:prstGeom>
+        </p:spPr>
+      </p:pic>
     </p:spTree>
   </p:cSld>
   <p:clrMapOvr>
@@ -9703,6 +9967,54 @@
           </a:p>
         </p:txBody>
       </p:sp>
+      <p:pic>
+        <p:nvPicPr>
+          <p:cNvPr id="26" name="Image 0" descr="bird">    </p:cNvPr>
+          <p:cNvPicPr>
+            <a:picLocks noChangeAspect="1"/>
+          </p:cNvPicPr>
+          <p:nvPr/>
+        </p:nvPicPr>
+        <p:blipFill>
+          <a:blip r:embed="rId1"/>
+          <a:stretch>
+            <a:fillRect/>
+          </a:stretch>
+        </p:blipFill>
+        <p:spPr>
+          <a:xfrm>
+            <a:off x="91440" y="3566160"/>
+            <a:ext cx="1338270" cy="1508760"/>
+          </a:xfrm>
+          <a:prstGeom prst="rect">
+            <a:avLst/>
+          </a:prstGeom>
+        </p:spPr>
+      </p:pic>
+      <p:pic>
+        <p:nvPicPr>
+          <p:cNvPr id="27" name="Image 1" descr="elephant">    </p:cNvPr>
+          <p:cNvPicPr>
+            <a:picLocks noChangeAspect="1"/>
+          </p:cNvPicPr>
+          <p:nvPr/>
+        </p:nvPicPr>
+        <p:blipFill>
+          <a:blip r:embed="rId2"/>
+          <a:stretch>
+            <a:fillRect/>
+          </a:stretch>
+        </p:blipFill>
+        <p:spPr>
+          <a:xfrm>
+            <a:off x="7113666" y="3337560"/>
+            <a:ext cx="1938894" cy="1737360"/>
+          </a:xfrm>
+          <a:prstGeom prst="rect">
+            <a:avLst/>
+          </a:prstGeom>
+        </p:spPr>
+      </p:pic>
     </p:spTree>
   </p:cSld>
   <p:clrMapOvr>
@@ -10975,6 +11287,78 @@
           </a:p>
         </p:txBody>
       </p:sp>
+      <p:pic>
+        <p:nvPicPr>
+          <p:cNvPr id="24" name="Image 0" descr="turtle">    </p:cNvPr>
+          <p:cNvPicPr>
+            <a:picLocks noChangeAspect="1"/>
+          </p:cNvPicPr>
+          <p:nvPr/>
+        </p:nvPicPr>
+        <p:blipFill>
+          <a:blip r:embed="rId1"/>
+          <a:stretch>
+            <a:fillRect/>
+          </a:stretch>
+        </p:blipFill>
+        <p:spPr>
+          <a:xfrm>
+            <a:off x="91440" y="3566160"/>
+            <a:ext cx="1546479" cy="1508760"/>
+          </a:xfrm>
+          <a:prstGeom prst="rect">
+            <a:avLst/>
+          </a:prstGeom>
+        </p:spPr>
+      </p:pic>
+      <p:pic>
+        <p:nvPicPr>
+          <p:cNvPr id="25" name="Image 1" descr="elephant">    </p:cNvPr>
+          <p:cNvPicPr>
+            <a:picLocks noChangeAspect="1"/>
+          </p:cNvPicPr>
+          <p:nvPr/>
+        </p:nvPicPr>
+        <p:blipFill>
+          <a:blip r:embed="rId2"/>
+          <a:stretch>
+            <a:fillRect/>
+          </a:stretch>
+        </p:blipFill>
+        <p:spPr>
+          <a:xfrm>
+            <a:off x="7012899" y="3337560"/>
+            <a:ext cx="2039661" cy="1737360"/>
+          </a:xfrm>
+          <a:prstGeom prst="rect">
+            <a:avLst/>
+          </a:prstGeom>
+        </p:spPr>
+      </p:pic>
+      <p:pic>
+        <p:nvPicPr>
+          <p:cNvPr id="26" name="Image 2" descr="bird4">    </p:cNvPr>
+          <p:cNvPicPr>
+            <a:picLocks noChangeAspect="1"/>
+          </p:cNvPicPr>
+          <p:nvPr/>
+        </p:nvPicPr>
+        <p:blipFill>
+          <a:blip r:embed="rId3"/>
+          <a:stretch>
+            <a:fillRect/>
+          </a:stretch>
+        </p:blipFill>
+        <p:spPr>
+          <a:xfrm flipH="1">
+            <a:off x="6216457" y="45720"/>
+            <a:ext cx="1007303" cy="777240"/>
+          </a:xfrm>
+          <a:prstGeom prst="rect">
+            <a:avLst/>
+          </a:prstGeom>
+        </p:spPr>
+      </p:pic>
     </p:spTree>
   </p:cSld>
   <p:clrMapOvr>
@@ -12309,6 +12693,30 @@
           </a:p>
         </p:txBody>
       </p:sp>
+      <p:pic>
+        <p:nvPicPr>
+          <p:cNvPr id="28" name="Image 0" descr="bee">    </p:cNvPr>
+          <p:cNvPicPr>
+            <a:picLocks noChangeAspect="1"/>
+          </p:cNvPicPr>
+          <p:nvPr/>
+        </p:nvPicPr>
+        <p:blipFill>
+          <a:blip r:embed="rId1"/>
+          <a:stretch>
+            <a:fillRect/>
+          </a:stretch>
+        </p:blipFill>
+        <p:spPr>
+          <a:xfrm>
+            <a:off x="1005840" y="45720"/>
+            <a:ext cx="802112" cy="777240"/>
+          </a:xfrm>
+          <a:prstGeom prst="rect">
+            <a:avLst/>
+          </a:prstGeom>
+        </p:spPr>
+      </p:pic>
     </p:spTree>
   </p:cSld>
   <p:clrMapOvr>
@@ -13408,6 +13816,78 @@
           </a:p>
         </p:txBody>
       </p:sp>
+      <p:pic>
+        <p:nvPicPr>
+          <p:cNvPr id="25" name="Image 0" descr="fish">    </p:cNvPr>
+          <p:cNvPicPr>
+            <a:picLocks noChangeAspect="1"/>
+          </p:cNvPicPr>
+          <p:nvPr/>
+        </p:nvPicPr>
+        <p:blipFill>
+          <a:blip r:embed="rId1"/>
+          <a:stretch>
+            <a:fillRect/>
+          </a:stretch>
+        </p:blipFill>
+        <p:spPr>
+          <a:xfrm>
+            <a:off x="91440" y="4343400"/>
+            <a:ext cx="909279" cy="731520"/>
+          </a:xfrm>
+          <a:prstGeom prst="rect">
+            <a:avLst/>
+          </a:prstGeom>
+        </p:spPr>
+      </p:pic>
+      <p:pic>
+        <p:nvPicPr>
+          <p:cNvPr id="26" name="Image 1" descr="bird">    </p:cNvPr>
+          <p:cNvPicPr>
+            <a:picLocks noChangeAspect="1"/>
+          </p:cNvPicPr>
+          <p:nvPr/>
+        </p:nvPicPr>
+        <p:blipFill>
+          <a:blip r:embed="rId2"/>
+          <a:stretch>
+            <a:fillRect/>
+          </a:stretch>
+        </p:blipFill>
+        <p:spPr>
+          <a:xfrm>
+            <a:off x="8480511" y="4343400"/>
+            <a:ext cx="572049" cy="731520"/>
+          </a:xfrm>
+          <a:prstGeom prst="rect">
+            <a:avLst/>
+          </a:prstGeom>
+        </p:spPr>
+      </p:pic>
+      <p:pic>
+        <p:nvPicPr>
+          <p:cNvPr id="27" name="Image 2" descr="bird2">    </p:cNvPr>
+          <p:cNvPicPr>
+            <a:picLocks noChangeAspect="1"/>
+          </p:cNvPicPr>
+          <p:nvPr/>
+        </p:nvPicPr>
+        <p:blipFill>
+          <a:blip r:embed="rId3"/>
+          <a:stretch>
+            <a:fillRect/>
+          </a:stretch>
+        </p:blipFill>
+        <p:spPr>
+          <a:xfrm flipH="1">
+            <a:off x="5505420" y="45720"/>
+            <a:ext cx="803940" cy="640080"/>
+          </a:xfrm>
+          <a:prstGeom prst="rect">
+            <a:avLst/>
+          </a:prstGeom>
+        </p:spPr>
+      </p:pic>
     </p:spTree>
   </p:cSld>
   <p:clrMapOvr>
@@ -14380,6 +14860,78 @@
           </a:p>
         </p:txBody>
       </p:sp>
+      <p:pic>
+        <p:nvPicPr>
+          <p:cNvPr id="20" name="Image 0" descr="elephant">    </p:cNvPr>
+          <p:cNvPicPr>
+            <a:picLocks noChangeAspect="1"/>
+          </p:cNvPicPr>
+          <p:nvPr/>
+        </p:nvPicPr>
+        <p:blipFill>
+          <a:blip r:embed="rId1"/>
+          <a:stretch>
+            <a:fillRect/>
+          </a:stretch>
+        </p:blipFill>
+        <p:spPr>
+          <a:xfrm>
+            <a:off x="91440" y="3657600"/>
+            <a:ext cx="1561887" cy="1417320"/>
+          </a:xfrm>
+          <a:prstGeom prst="rect">
+            <a:avLst/>
+          </a:prstGeom>
+        </p:spPr>
+      </p:pic>
+      <p:pic>
+        <p:nvPicPr>
+          <p:cNvPr id="21" name="Image 1" descr="bird">    </p:cNvPr>
+          <p:cNvPicPr>
+            <a:picLocks noChangeAspect="1"/>
+          </p:cNvPicPr>
+          <p:nvPr/>
+        </p:nvPicPr>
+        <p:blipFill>
+          <a:blip r:embed="rId2"/>
+          <a:stretch>
+            <a:fillRect/>
+          </a:stretch>
+        </p:blipFill>
+        <p:spPr>
+          <a:xfrm>
+            <a:off x="7986187" y="3520440"/>
+            <a:ext cx="1066373" cy="1554480"/>
+          </a:xfrm>
+          <a:prstGeom prst="rect">
+            <a:avLst/>
+          </a:prstGeom>
+        </p:spPr>
+      </p:pic>
+      <p:pic>
+        <p:nvPicPr>
+          <p:cNvPr id="22" name="Image 2" descr="butterfly1">    </p:cNvPr>
+          <p:cNvPicPr>
+            <a:picLocks noChangeAspect="1"/>
+          </p:cNvPicPr>
+          <p:nvPr/>
+        </p:nvPicPr>
+        <p:blipFill>
+          <a:blip r:embed="rId3"/>
+          <a:stretch>
+            <a:fillRect/>
+          </a:stretch>
+        </p:blipFill>
+        <p:spPr>
+          <a:xfrm>
+            <a:off x="1920240" y="45720"/>
+            <a:ext cx="906262" cy="777240"/>
+          </a:xfrm>
+          <a:prstGeom prst="rect">
+            <a:avLst/>
+          </a:prstGeom>
+        </p:spPr>
+      </p:pic>
     </p:spTree>
   </p:cSld>
   <p:clrMapOvr>
@@ -15377,6 +15929,78 @@
           </a:p>
         </p:txBody>
       </p:sp>
+      <p:pic>
+        <p:nvPicPr>
+          <p:cNvPr id="21" name="Image 0" descr="duck">    </p:cNvPr>
+          <p:cNvPicPr>
+            <a:picLocks noChangeAspect="1"/>
+          </p:cNvPicPr>
+          <p:nvPr/>
+        </p:nvPicPr>
+        <p:blipFill>
+          <a:blip r:embed="rId1"/>
+          <a:stretch>
+            <a:fillRect/>
+          </a:stretch>
+        </p:blipFill>
+        <p:spPr>
+          <a:xfrm>
+            <a:off x="91440" y="3794760"/>
+            <a:ext cx="1081735" cy="1280160"/>
+          </a:xfrm>
+          <a:prstGeom prst="rect">
+            <a:avLst/>
+          </a:prstGeom>
+        </p:spPr>
+      </p:pic>
+      <p:pic>
+        <p:nvPicPr>
+          <p:cNvPr id="22" name="Image 1" descr="bird">    </p:cNvPr>
+          <p:cNvPicPr>
+            <a:picLocks noChangeAspect="1"/>
+          </p:cNvPicPr>
+          <p:nvPr/>
+        </p:nvPicPr>
+        <p:blipFill>
+          <a:blip r:embed="rId2"/>
+          <a:stretch>
+            <a:fillRect/>
+          </a:stretch>
+        </p:blipFill>
+        <p:spPr>
+          <a:xfrm>
+            <a:off x="8349752" y="4251960"/>
+            <a:ext cx="702808" cy="822960"/>
+          </a:xfrm>
+          <a:prstGeom prst="rect">
+            <a:avLst/>
+          </a:prstGeom>
+        </p:spPr>
+      </p:pic>
+      <p:pic>
+        <p:nvPicPr>
+          <p:cNvPr id="23" name="Image 2" descr="bird1">    </p:cNvPr>
+          <p:cNvPicPr>
+            <a:picLocks noChangeAspect="1"/>
+          </p:cNvPicPr>
+          <p:nvPr/>
+        </p:nvPicPr>
+        <p:blipFill>
+          <a:blip r:embed="rId3"/>
+          <a:stretch>
+            <a:fillRect/>
+          </a:stretch>
+        </p:blipFill>
+        <p:spPr>
+          <a:xfrm flipH="1">
+            <a:off x="5302057" y="45720"/>
+            <a:ext cx="1007303" cy="777240"/>
+          </a:xfrm>
+          <a:prstGeom prst="rect">
+            <a:avLst/>
+          </a:prstGeom>
+        </p:spPr>
+      </p:pic>
     </p:spTree>
   </p:cSld>
   <p:clrMapOvr>
@@ -16399,6 +17023,54 @@
           </a:p>
         </p:txBody>
       </p:sp>
+      <p:pic>
+        <p:nvPicPr>
+          <p:cNvPr id="22" name="Image 0" descr="elephant">    </p:cNvPr>
+          <p:cNvPicPr>
+            <a:picLocks noChangeAspect="1"/>
+          </p:cNvPicPr>
+          <p:nvPr/>
+        </p:nvPicPr>
+        <p:blipFill>
+          <a:blip r:embed="rId1"/>
+          <a:stretch>
+            <a:fillRect/>
+          </a:stretch>
+        </p:blipFill>
+        <p:spPr>
+          <a:xfrm>
+            <a:off x="91440" y="3657600"/>
+            <a:ext cx="1561887" cy="1417320"/>
+          </a:xfrm>
+          <a:prstGeom prst="rect">
+            <a:avLst/>
+          </a:prstGeom>
+        </p:spPr>
+      </p:pic>
+      <p:pic>
+        <p:nvPicPr>
+          <p:cNvPr id="23" name="Image 1" descr="bird">    </p:cNvPr>
+          <p:cNvPicPr>
+            <a:picLocks noChangeAspect="1"/>
+          </p:cNvPicPr>
+          <p:nvPr/>
+        </p:nvPicPr>
+        <p:blipFill>
+          <a:blip r:embed="rId2"/>
+          <a:stretch>
+            <a:fillRect/>
+          </a:stretch>
+        </p:blipFill>
+        <p:spPr>
+          <a:xfrm>
+            <a:off x="7986187" y="3520440"/>
+            <a:ext cx="1066373" cy="1554480"/>
+          </a:xfrm>
+          <a:prstGeom prst="rect">
+            <a:avLst/>
+          </a:prstGeom>
+        </p:spPr>
+      </p:pic>
     </p:spTree>
   </p:cSld>
   <p:clrMapOvr>
@@ -17421,6 +18093,54 @@
           </a:p>
         </p:txBody>
       </p:sp>
+      <p:pic>
+        <p:nvPicPr>
+          <p:cNvPr id="22" name="Image 0" descr="dog">    </p:cNvPr>
+          <p:cNvPicPr>
+            <a:picLocks noChangeAspect="1"/>
+          </p:cNvPicPr>
+          <p:nvPr/>
+        </p:nvPicPr>
+        <p:blipFill>
+          <a:blip r:embed="rId1"/>
+          <a:stretch>
+            <a:fillRect/>
+          </a:stretch>
+        </p:blipFill>
+        <p:spPr>
+          <a:xfrm>
+            <a:off x="91440" y="3657600"/>
+            <a:ext cx="1339367" cy="1417320"/>
+          </a:xfrm>
+          <a:prstGeom prst="rect">
+            <a:avLst/>
+          </a:prstGeom>
+        </p:spPr>
+      </p:pic>
+      <p:pic>
+        <p:nvPicPr>
+          <p:cNvPr id="23" name="Image 1" descr="bird">    </p:cNvPr>
+          <p:cNvPicPr>
+            <a:picLocks noChangeAspect="1"/>
+          </p:cNvPicPr>
+          <p:nvPr/>
+        </p:nvPicPr>
+        <p:blipFill>
+          <a:blip r:embed="rId2"/>
+          <a:stretch>
+            <a:fillRect/>
+          </a:stretch>
+        </p:blipFill>
+        <p:spPr>
+          <a:xfrm>
+            <a:off x="7894472" y="3520440"/>
+            <a:ext cx="1158088" cy="1554480"/>
+          </a:xfrm>
+          <a:prstGeom prst="rect">
+            <a:avLst/>
+          </a:prstGeom>
+        </p:spPr>
+      </p:pic>
     </p:spTree>
   </p:cSld>
   <p:clrMapOvr>
@@ -18403,6 +19123,78 @@
           </a:p>
         </p:txBody>
       </p:sp>
+      <p:pic>
+        <p:nvPicPr>
+          <p:cNvPr id="20" name="Image 0" descr="cat">    </p:cNvPr>
+          <p:cNvPicPr>
+            <a:picLocks noChangeAspect="1"/>
+          </p:cNvPicPr>
+          <p:nvPr/>
+        </p:nvPicPr>
+        <p:blipFill>
+          <a:blip r:embed="rId1"/>
+          <a:stretch>
+            <a:fillRect/>
+          </a:stretch>
+        </p:blipFill>
+        <p:spPr>
+          <a:xfrm>
+            <a:off x="91440" y="3657600"/>
+            <a:ext cx="1206139" cy="1417320"/>
+          </a:xfrm>
+          <a:prstGeom prst="rect">
+            <a:avLst/>
+          </a:prstGeom>
+        </p:spPr>
+      </p:pic>
+      <p:pic>
+        <p:nvPicPr>
+          <p:cNvPr id="21" name="Image 1" descr="elephant">    </p:cNvPr>
+          <p:cNvPicPr>
+            <a:picLocks noChangeAspect="1"/>
+          </p:cNvPicPr>
+          <p:nvPr/>
+        </p:nvPicPr>
+        <p:blipFill>
+          <a:blip r:embed="rId2"/>
+          <a:stretch>
+            <a:fillRect/>
+          </a:stretch>
+        </p:blipFill>
+        <p:spPr>
+          <a:xfrm>
+            <a:off x="7493417" y="3520440"/>
+            <a:ext cx="1559143" cy="1554480"/>
+          </a:xfrm>
+          <a:prstGeom prst="rect">
+            <a:avLst/>
+          </a:prstGeom>
+        </p:spPr>
+      </p:pic>
+      <p:pic>
+        <p:nvPicPr>
+          <p:cNvPr id="22" name="Image 2" descr="bee">    </p:cNvPr>
+          <p:cNvPicPr>
+            <a:picLocks noChangeAspect="1"/>
+          </p:cNvPicPr>
+          <p:nvPr/>
+        </p:nvPicPr>
+        <p:blipFill>
+          <a:blip r:embed="rId3"/>
+          <a:stretch>
+            <a:fillRect/>
+          </a:stretch>
+        </p:blipFill>
+        <p:spPr>
+          <a:xfrm>
+            <a:off x="6421648" y="45720"/>
+            <a:ext cx="802112" cy="777240"/>
+          </a:xfrm>
+          <a:prstGeom prst="rect">
+            <a:avLst/>
+          </a:prstGeom>
+        </p:spPr>
+      </p:pic>
     </p:spTree>
   </p:cSld>
   <p:clrMapOvr>
@@ -19575,6 +20367,30 @@
           </a:p>
         </p:txBody>
       </p:sp>
+      <p:pic>
+        <p:nvPicPr>
+          <p:cNvPr id="28" name="Image 0" descr="bird2">    </p:cNvPr>
+          <p:cNvPicPr>
+            <a:picLocks noChangeAspect="1"/>
+          </p:cNvPicPr>
+          <p:nvPr/>
+        </p:nvPicPr>
+        <p:blipFill>
+          <a:blip r:embed="rId1"/>
+          <a:stretch>
+            <a:fillRect/>
+          </a:stretch>
+        </p:blipFill>
+        <p:spPr>
+          <a:xfrm>
+            <a:off x="1005840" y="45720"/>
+            <a:ext cx="976213" cy="777240"/>
+          </a:xfrm>
+          <a:prstGeom prst="rect">
+            <a:avLst/>
+          </a:prstGeom>
+        </p:spPr>
+      </p:pic>
     </p:spTree>
   </p:cSld>
   <p:clrMapOvr>
@@ -20575,6 +21391,78 @@
           </a:p>
         </p:txBody>
       </p:sp>
+      <p:pic>
+        <p:nvPicPr>
+          <p:cNvPr id="22" name="Image 0" descr="turtle">    </p:cNvPr>
+          <p:cNvPicPr>
+            <a:picLocks noChangeAspect="1"/>
+          </p:cNvPicPr>
+          <p:nvPr/>
+        </p:nvPicPr>
+        <p:blipFill>
+          <a:blip r:embed="rId1"/>
+          <a:stretch>
+            <a:fillRect/>
+          </a:stretch>
+        </p:blipFill>
+        <p:spPr>
+          <a:xfrm>
+            <a:off x="91440" y="1783080"/>
+            <a:ext cx="1593342" cy="1554480"/>
+          </a:xfrm>
+          <a:prstGeom prst="rect">
+            <a:avLst/>
+          </a:prstGeom>
+        </p:spPr>
+      </p:pic>
+      <p:pic>
+        <p:nvPicPr>
+          <p:cNvPr id="23" name="Image 1" descr="elephant">    </p:cNvPr>
+          <p:cNvPicPr>
+            <a:picLocks noChangeAspect="1"/>
+          </p:cNvPicPr>
+          <p:nvPr/>
+        </p:nvPicPr>
+        <p:blipFill>
+          <a:blip r:embed="rId2"/>
+          <a:stretch>
+            <a:fillRect/>
+          </a:stretch>
+        </p:blipFill>
+        <p:spPr>
+          <a:xfrm>
+            <a:off x="7227600" y="1783080"/>
+            <a:ext cx="1824960" cy="1554480"/>
+          </a:xfrm>
+          <a:prstGeom prst="rect">
+            <a:avLst/>
+          </a:prstGeom>
+        </p:spPr>
+      </p:pic>
+      <p:pic>
+        <p:nvPicPr>
+          <p:cNvPr id="24" name="Image 2" descr="butterfly1">    </p:cNvPr>
+          <p:cNvPicPr>
+            <a:picLocks noChangeAspect="1"/>
+          </p:cNvPicPr>
+          <p:nvPr/>
+        </p:nvPicPr>
+        <p:blipFill>
+          <a:blip r:embed="rId3"/>
+          <a:stretch>
+            <a:fillRect/>
+          </a:stretch>
+        </p:blipFill>
+        <p:spPr>
+          <a:xfrm>
+            <a:off x="5456408" y="45720"/>
+            <a:ext cx="852952" cy="731520"/>
+          </a:xfrm>
+          <a:prstGeom prst="rect">
+            <a:avLst/>
+          </a:prstGeom>
+        </p:spPr>
+      </p:pic>
     </p:spTree>
   </p:cSld>
   <p:clrMapOvr>
@@ -21376,6 +22264,78 @@
           </a:p>
         </p:txBody>
       </p:sp>
+      <p:pic>
+        <p:nvPicPr>
+          <p:cNvPr id="17" name="Image 0" descr="rabbit">    </p:cNvPr>
+          <p:cNvPicPr>
+            <a:picLocks noChangeAspect="1"/>
+          </p:cNvPicPr>
+          <p:nvPr/>
+        </p:nvPicPr>
+        <p:blipFill>
+          <a:blip r:embed="rId1"/>
+          <a:stretch>
+            <a:fillRect/>
+          </a:stretch>
+        </p:blipFill>
+        <p:spPr>
+          <a:xfrm>
+            <a:off x="91440" y="1783080"/>
+            <a:ext cx="1162751" cy="1554480"/>
+          </a:xfrm>
+          <a:prstGeom prst="rect">
+            <a:avLst/>
+          </a:prstGeom>
+        </p:spPr>
+      </p:pic>
+      <p:pic>
+        <p:nvPicPr>
+          <p:cNvPr id="18" name="Image 1" descr="elephant">    </p:cNvPr>
+          <p:cNvPicPr>
+            <a:picLocks noChangeAspect="1"/>
+          </p:cNvPicPr>
+          <p:nvPr/>
+        </p:nvPicPr>
+        <p:blipFill>
+          <a:blip r:embed="rId2"/>
+          <a:stretch>
+            <a:fillRect/>
+          </a:stretch>
+        </p:blipFill>
+        <p:spPr>
+          <a:xfrm>
+            <a:off x="7299107" y="1783080"/>
+            <a:ext cx="1753453" cy="1554480"/>
+          </a:xfrm>
+          <a:prstGeom prst="rect">
+            <a:avLst/>
+          </a:prstGeom>
+        </p:spPr>
+      </p:pic>
+      <p:pic>
+        <p:nvPicPr>
+          <p:cNvPr id="19" name="Image 2" descr="bird1">    </p:cNvPr>
+          <p:cNvPicPr>
+            <a:picLocks noChangeAspect="1"/>
+          </p:cNvPicPr>
+          <p:nvPr/>
+        </p:nvPicPr>
+        <p:blipFill>
+          <a:blip r:embed="rId3"/>
+          <a:stretch>
+            <a:fillRect/>
+          </a:stretch>
+        </p:blipFill>
+        <p:spPr>
+          <a:xfrm>
+            <a:off x="1920240" y="45720"/>
+            <a:ext cx="888797" cy="685800"/>
+          </a:xfrm>
+          <a:prstGeom prst="rect">
+            <a:avLst/>
+          </a:prstGeom>
+        </p:spPr>
+      </p:pic>
     </p:spTree>
   </p:cSld>
   <p:clrMapOvr>
@@ -22202,6 +23162,78 @@
           </a:p>
         </p:txBody>
       </p:sp>
+      <p:pic>
+        <p:nvPicPr>
+          <p:cNvPr id="18" name="Image 0" descr="fish">    </p:cNvPr>
+          <p:cNvPicPr>
+            <a:picLocks noChangeAspect="1"/>
+          </p:cNvPicPr>
+          <p:nvPr/>
+        </p:nvPicPr>
+        <p:blipFill>
+          <a:blip r:embed="rId1"/>
+          <a:stretch>
+            <a:fillRect/>
+          </a:stretch>
+        </p:blipFill>
+        <p:spPr>
+          <a:xfrm>
+            <a:off x="91440" y="1783080"/>
+            <a:ext cx="1932219" cy="1554480"/>
+          </a:xfrm>
+          <a:prstGeom prst="rect">
+            <a:avLst/>
+          </a:prstGeom>
+        </p:spPr>
+      </p:pic>
+      <p:pic>
+        <p:nvPicPr>
+          <p:cNvPr id="19" name="Image 1" descr="bird">    </p:cNvPr>
+          <p:cNvPicPr>
+            <a:picLocks noChangeAspect="1"/>
+          </p:cNvPicPr>
+          <p:nvPr/>
+        </p:nvPicPr>
+        <p:blipFill>
+          <a:blip r:embed="rId2"/>
+          <a:stretch>
+            <a:fillRect/>
+          </a:stretch>
+        </p:blipFill>
+        <p:spPr>
+          <a:xfrm>
+            <a:off x="7836957" y="1783080"/>
+            <a:ext cx="1215603" cy="1554480"/>
+          </a:xfrm>
+          <a:prstGeom prst="rect">
+            <a:avLst/>
+          </a:prstGeom>
+        </p:spPr>
+      </p:pic>
+      <p:pic>
+        <p:nvPicPr>
+          <p:cNvPr id="20" name="Image 2" descr="bird4">    </p:cNvPr>
+          <p:cNvPicPr>
+            <a:picLocks noChangeAspect="1"/>
+          </p:cNvPicPr>
+          <p:nvPr/>
+        </p:nvPicPr>
+        <p:blipFill>
+          <a:blip r:embed="rId3"/>
+          <a:stretch>
+            <a:fillRect/>
+          </a:stretch>
+        </p:blipFill>
+        <p:spPr>
+          <a:xfrm flipH="1">
+            <a:off x="5302057" y="45720"/>
+            <a:ext cx="1007303" cy="777240"/>
+          </a:xfrm>
+          <a:prstGeom prst="rect">
+            <a:avLst/>
+          </a:prstGeom>
+        </p:spPr>
+      </p:pic>
     </p:spTree>
   </p:cSld>
   <p:clrMapOvr>
@@ -23053,6 +24085,54 @@
           </a:p>
         </p:txBody>
       </p:sp>
+      <p:pic>
+        <p:nvPicPr>
+          <p:cNvPr id="19" name="Image 0" descr="elephant">    </p:cNvPr>
+          <p:cNvPicPr>
+            <a:picLocks noChangeAspect="1"/>
+          </p:cNvPicPr>
+          <p:nvPr/>
+        </p:nvPicPr>
+        <p:blipFill>
+          <a:blip r:embed="rId1"/>
+          <a:stretch>
+            <a:fillRect/>
+          </a:stretch>
+        </p:blipFill>
+        <p:spPr>
+          <a:xfrm>
+            <a:off x="91440" y="1783080"/>
+            <a:ext cx="1713037" cy="1554480"/>
+          </a:xfrm>
+          <a:prstGeom prst="rect">
+            <a:avLst/>
+          </a:prstGeom>
+        </p:spPr>
+      </p:pic>
+      <p:pic>
+        <p:nvPicPr>
+          <p:cNvPr id="20" name="Image 1" descr="bird">    </p:cNvPr>
+          <p:cNvPicPr>
+            <a:picLocks noChangeAspect="1"/>
+          </p:cNvPicPr>
+          <p:nvPr/>
+        </p:nvPicPr>
+        <p:blipFill>
+          <a:blip r:embed="rId2"/>
+          <a:stretch>
+            <a:fillRect/>
+          </a:stretch>
+        </p:blipFill>
+        <p:spPr>
+          <a:xfrm>
+            <a:off x="7986187" y="1783080"/>
+            <a:ext cx="1066373" cy="1554480"/>
+          </a:xfrm>
+          <a:prstGeom prst="rect">
+            <a:avLst/>
+          </a:prstGeom>
+        </p:spPr>
+      </p:pic>
     </p:spTree>
   </p:cSld>
   <p:clrMapOvr>
@@ -23963,6 +25043,78 @@
           </a:p>
         </p:txBody>
       </p:sp>
+      <p:pic>
+        <p:nvPicPr>
+          <p:cNvPr id="20" name="Image 0" descr="duck">    </p:cNvPr>
+          <p:cNvPicPr>
+            <a:picLocks noChangeAspect="1"/>
+          </p:cNvPicPr>
+          <p:nvPr/>
+        </p:nvPicPr>
+        <p:blipFill>
+          <a:blip r:embed="rId1"/>
+          <a:stretch>
+            <a:fillRect/>
+          </a:stretch>
+        </p:blipFill>
+        <p:spPr>
+          <a:xfrm>
+            <a:off x="91440" y="3657600"/>
+            <a:ext cx="1197635" cy="1417320"/>
+          </a:xfrm>
+          <a:prstGeom prst="rect">
+            <a:avLst/>
+          </a:prstGeom>
+        </p:spPr>
+      </p:pic>
+      <p:pic>
+        <p:nvPicPr>
+          <p:cNvPr id="21" name="Image 1" descr="bird">    </p:cNvPr>
+          <p:cNvPicPr>
+            <a:picLocks noChangeAspect="1"/>
+          </p:cNvPicPr>
+          <p:nvPr/>
+        </p:nvPicPr>
+        <p:blipFill>
+          <a:blip r:embed="rId2"/>
+          <a:stretch>
+            <a:fillRect/>
+          </a:stretch>
+        </p:blipFill>
+        <p:spPr>
+          <a:xfrm>
+            <a:off x="7725034" y="3520440"/>
+            <a:ext cx="1327526" cy="1554480"/>
+          </a:xfrm>
+          <a:prstGeom prst="rect">
+            <a:avLst/>
+          </a:prstGeom>
+        </p:spPr>
+      </p:pic>
+      <p:pic>
+        <p:nvPicPr>
+          <p:cNvPr id="22" name="Image 2" descr="butterfly1">    </p:cNvPr>
+          <p:cNvPicPr>
+            <a:picLocks noChangeAspect="1"/>
+          </p:cNvPicPr>
+          <p:nvPr/>
+        </p:nvPicPr>
+        <p:blipFill>
+          <a:blip r:embed="rId3"/>
+          <a:stretch>
+            <a:fillRect/>
+          </a:stretch>
+        </p:blipFill>
+        <p:spPr>
+          <a:xfrm>
+            <a:off x="6317498" y="45720"/>
+            <a:ext cx="906262" cy="777240"/>
+          </a:xfrm>
+          <a:prstGeom prst="rect">
+            <a:avLst/>
+          </a:prstGeom>
+        </p:spPr>
+      </p:pic>
     </p:spTree>
   </p:cSld>
   <p:clrMapOvr>
@@ -25135,6 +26287,30 @@
           </a:p>
         </p:txBody>
       </p:sp>
+      <p:pic>
+        <p:nvPicPr>
+          <p:cNvPr id="28" name="Image 0" descr="bird1">    </p:cNvPr>
+          <p:cNvPicPr>
+            <a:picLocks noChangeAspect="1"/>
+          </p:cNvPicPr>
+          <p:nvPr/>
+        </p:nvPicPr>
+        <p:blipFill>
+          <a:blip r:embed="rId1"/>
+          <a:stretch>
+            <a:fillRect/>
+          </a:stretch>
+        </p:blipFill>
+        <p:spPr>
+          <a:xfrm>
+            <a:off x="1005840" y="45720"/>
+            <a:ext cx="1007303" cy="777240"/>
+          </a:xfrm>
+          <a:prstGeom prst="rect">
+            <a:avLst/>
+          </a:prstGeom>
+        </p:spPr>
+      </p:pic>
     </p:spTree>
   </p:cSld>
   <p:clrMapOvr>
@@ -26234,6 +27410,54 @@
           </a:p>
         </p:txBody>
       </p:sp>
+      <p:pic>
+        <p:nvPicPr>
+          <p:cNvPr id="25" name="Image 0" descr="cat">    </p:cNvPr>
+          <p:cNvPicPr>
+            <a:picLocks noChangeAspect="1"/>
+          </p:cNvPicPr>
+          <p:nvPr/>
+        </p:nvPicPr>
+        <p:blipFill>
+          <a:blip r:embed="rId1"/>
+          <a:stretch>
+            <a:fillRect/>
+          </a:stretch>
+        </p:blipFill>
+        <p:spPr>
+          <a:xfrm>
+            <a:off x="91440" y="4023360"/>
+            <a:ext cx="894878" cy="1051560"/>
+          </a:xfrm>
+          <a:prstGeom prst="rect">
+            <a:avLst/>
+          </a:prstGeom>
+        </p:spPr>
+      </p:pic>
+      <p:pic>
+        <p:nvPicPr>
+          <p:cNvPr id="26" name="Image 1" descr="bird4">    </p:cNvPr>
+          <p:cNvPicPr>
+            <a:picLocks noChangeAspect="1"/>
+          </p:cNvPicPr>
+          <p:nvPr/>
+        </p:nvPicPr>
+        <p:blipFill>
+          <a:blip r:embed="rId2"/>
+          <a:stretch>
+            <a:fillRect/>
+          </a:stretch>
+        </p:blipFill>
+        <p:spPr>
+          <a:xfrm flipH="1">
+            <a:off x="5479816" y="45720"/>
+            <a:ext cx="829544" cy="640080"/>
+          </a:xfrm>
+          <a:prstGeom prst="rect">
+            <a:avLst/>
+          </a:prstGeom>
+        </p:spPr>
+      </p:pic>
     </p:spTree>
   </p:cSld>
   <p:clrMapOvr>
@@ -27206,6 +28430,78 @@
           </a:p>
         </p:txBody>
       </p:sp>
+      <p:pic>
+        <p:nvPicPr>
+          <p:cNvPr id="20" name="Image 0" descr="bird">    </p:cNvPr>
+          <p:cNvPicPr>
+            <a:picLocks noChangeAspect="1"/>
+          </p:cNvPicPr>
+          <p:nvPr/>
+        </p:nvPicPr>
+        <p:blipFill>
+          <a:blip r:embed="rId1"/>
+          <a:stretch>
+            <a:fillRect/>
+          </a:stretch>
+        </p:blipFill>
+        <p:spPr>
+          <a:xfrm>
+            <a:off x="91440" y="3657600"/>
+            <a:ext cx="1257163" cy="1417320"/>
+          </a:xfrm>
+          <a:prstGeom prst="rect">
+            <a:avLst/>
+          </a:prstGeom>
+        </p:spPr>
+      </p:pic>
+      <p:pic>
+        <p:nvPicPr>
+          <p:cNvPr id="21" name="Image 1" descr="elephant">    </p:cNvPr>
+          <p:cNvPicPr>
+            <a:picLocks noChangeAspect="1"/>
+          </p:cNvPicPr>
+          <p:nvPr/>
+        </p:nvPicPr>
+        <p:blipFill>
+          <a:blip r:embed="rId2"/>
+          <a:stretch>
+            <a:fillRect/>
+          </a:stretch>
+        </p:blipFill>
+        <p:spPr>
+          <a:xfrm>
+            <a:off x="7317760" y="3520440"/>
+            <a:ext cx="1734800" cy="1554480"/>
+          </a:xfrm>
+          <a:prstGeom prst="rect">
+            <a:avLst/>
+          </a:prstGeom>
+        </p:spPr>
+      </p:pic>
+      <p:pic>
+        <p:nvPicPr>
+          <p:cNvPr id="22" name="Image 2" descr="bee">    </p:cNvPr>
+          <p:cNvPicPr>
+            <a:picLocks noChangeAspect="1"/>
+          </p:cNvPicPr>
+          <p:nvPr/>
+        </p:nvPicPr>
+        <p:blipFill>
+          <a:blip r:embed="rId3"/>
+          <a:stretch>
+            <a:fillRect/>
+          </a:stretch>
+        </p:blipFill>
+        <p:spPr>
+          <a:xfrm>
+            <a:off x="1920240" y="45720"/>
+            <a:ext cx="802112" cy="777240"/>
+          </a:xfrm>
+          <a:prstGeom prst="rect">
+            <a:avLst/>
+          </a:prstGeom>
+        </p:spPr>
+      </p:pic>
     </p:spTree>
   </p:cSld>
   <p:clrMapOvr>
@@ -28203,6 +29499,54 @@
           </a:p>
         </p:txBody>
       </p:sp>
+      <p:pic>
+        <p:nvPicPr>
+          <p:cNvPr id="21" name="Image 0" descr="turtle">    </p:cNvPr>
+          <p:cNvPicPr>
+            <a:picLocks noChangeAspect="1"/>
+          </p:cNvPicPr>
+          <p:nvPr/>
+        </p:nvPicPr>
+        <p:blipFill>
+          <a:blip r:embed="rId1"/>
+          <a:stretch>
+            <a:fillRect/>
+          </a:stretch>
+        </p:blipFill>
+        <p:spPr>
+          <a:xfrm>
+            <a:off x="91440" y="4023360"/>
+            <a:ext cx="1077849" cy="1051560"/>
+          </a:xfrm>
+          <a:prstGeom prst="rect">
+            <a:avLst/>
+          </a:prstGeom>
+        </p:spPr>
+      </p:pic>
+      <p:pic>
+        <p:nvPicPr>
+          <p:cNvPr id="22" name="Image 1" descr="bird2">    </p:cNvPr>
+          <p:cNvPicPr>
+            <a:picLocks noChangeAspect="1"/>
+          </p:cNvPicPr>
+          <p:nvPr/>
+        </p:nvPicPr>
+        <p:blipFill>
+          <a:blip r:embed="rId2"/>
+          <a:stretch>
+            <a:fillRect/>
+          </a:stretch>
+        </p:blipFill>
+        <p:spPr>
+          <a:xfrm flipH="1">
+            <a:off x="5333147" y="45720"/>
+            <a:ext cx="976213" cy="777240"/>
+          </a:xfrm>
+          <a:prstGeom prst="rect">
+            <a:avLst/>
+          </a:prstGeom>
+        </p:spPr>
+      </p:pic>
     </p:spTree>
   </p:cSld>
   <p:clrMapOvr>
@@ -29225,6 +30569,54 @@
           </a:p>
         </p:txBody>
       </p:sp>
+      <p:pic>
+        <p:nvPicPr>
+          <p:cNvPr id="22" name="Image 0" descr="rabbit">    </p:cNvPr>
+          <p:cNvPicPr>
+            <a:picLocks noChangeAspect="1"/>
+          </p:cNvPicPr>
+          <p:nvPr/>
+        </p:nvPicPr>
+        <p:blipFill>
+          <a:blip r:embed="rId1"/>
+          <a:stretch>
+            <a:fillRect/>
+          </a:stretch>
+        </p:blipFill>
+        <p:spPr>
+          <a:xfrm>
+            <a:off x="91440" y="3657600"/>
+            <a:ext cx="1060155" cy="1417320"/>
+          </a:xfrm>
+          <a:prstGeom prst="rect">
+            <a:avLst/>
+          </a:prstGeom>
+        </p:spPr>
+      </p:pic>
+      <p:pic>
+        <p:nvPicPr>
+          <p:cNvPr id="23" name="Image 1" descr="elephant">    </p:cNvPr>
+          <p:cNvPicPr>
+            <a:picLocks noChangeAspect="1"/>
+          </p:cNvPicPr>
+          <p:nvPr/>
+        </p:nvPicPr>
+        <p:blipFill>
+          <a:blip r:embed="rId2"/>
+          <a:stretch>
+            <a:fillRect/>
+          </a:stretch>
+        </p:blipFill>
+        <p:spPr>
+          <a:xfrm>
+            <a:off x="7299107" y="3520440"/>
+            <a:ext cx="1753453" cy="1554480"/>
+          </a:xfrm>
+          <a:prstGeom prst="rect">
+            <a:avLst/>
+          </a:prstGeom>
+        </p:spPr>
+      </p:pic>
     </p:spTree>
   </p:cSld>
   <p:clrMapOvr>
@@ -30335,6 +31727,78 @@
           </a:p>
         </p:txBody>
       </p:sp>
+      <p:pic>
+        <p:nvPicPr>
+          <p:cNvPr id="24" name="Image 0" descr="fish">    </p:cNvPr>
+          <p:cNvPicPr>
+            <a:picLocks noChangeAspect="1"/>
+          </p:cNvPicPr>
+          <p:nvPr/>
+        </p:nvPicPr>
+        <p:blipFill>
+          <a:blip r:embed="rId1"/>
+          <a:stretch>
+            <a:fillRect/>
+          </a:stretch>
+        </p:blipFill>
+        <p:spPr>
+          <a:xfrm>
+            <a:off x="91440" y="3566160"/>
+            <a:ext cx="1875389" cy="1508760"/>
+          </a:xfrm>
+          <a:prstGeom prst="rect">
+            <a:avLst/>
+          </a:prstGeom>
+        </p:spPr>
+      </p:pic>
+      <p:pic>
+        <p:nvPicPr>
+          <p:cNvPr id="25" name="Image 1" descr="bird">    </p:cNvPr>
+          <p:cNvPicPr>
+            <a:picLocks noChangeAspect="1"/>
+          </p:cNvPicPr>
+          <p:nvPr/>
+        </p:nvPicPr>
+        <p:blipFill>
+          <a:blip r:embed="rId2"/>
+          <a:stretch>
+            <a:fillRect/>
+          </a:stretch>
+        </p:blipFill>
+        <p:spPr>
+          <a:xfrm>
+            <a:off x="7693944" y="3337560"/>
+            <a:ext cx="1358616" cy="1737360"/>
+          </a:xfrm>
+          <a:prstGeom prst="rect">
+            <a:avLst/>
+          </a:prstGeom>
+        </p:spPr>
+      </p:pic>
+      <p:pic>
+        <p:nvPicPr>
+          <p:cNvPr id="26" name="Image 2" descr="bird1">    </p:cNvPr>
+          <p:cNvPicPr>
+            <a:picLocks noChangeAspect="1"/>
+          </p:cNvPicPr>
+          <p:nvPr/>
+        </p:nvPicPr>
+        <p:blipFill>
+          <a:blip r:embed="rId3"/>
+          <a:stretch>
+            <a:fillRect/>
+          </a:stretch>
+        </p:blipFill>
+        <p:spPr>
+          <a:xfrm flipH="1">
+            <a:off x="6216457" y="45720"/>
+            <a:ext cx="1007303" cy="777240"/>
+          </a:xfrm>
+          <a:prstGeom prst="rect">
+            <a:avLst/>
+          </a:prstGeom>
+        </p:spPr>
+      </p:pic>
     </p:spTree>
   </p:cSld>
   <p:clrMapOvr>

</xml_diff>